<commit_message>
Add Decryption and FI
</commit_message>
<xml_diff>
--- a/docs/presentations/SM4_PPT.pptx
+++ b/docs/presentations/SM4_PPT.pptx
@@ -12630,7 +12630,7 @@
         <p:spPr>
           <a:xfrm>
             <a:off x="9006348" y="2525661"/>
-            <a:ext cx="1071716" cy="381000"/>
+            <a:ext cx="1209368" cy="369332"/>
           </a:xfrm>
           <a:prstGeom prst="rect">
             <a:avLst/>
@@ -12654,7 +12654,7 @@
                 <a:effectLst/>
                 <a:latin typeface="+mn-lt"/>
               </a:rPr>
-              <a:t>B &lt;&lt;&lt; 2</a:t>
+              <a:t>B &lt;&lt;&lt; 10</a:t>
             </a:r>
             <a:endParaRPr lang="pt-BR" sz="1050" b="0" i="0" dirty="0">
               <a:solidFill>
@@ -12681,7 +12681,7 @@
         <p:spPr>
           <a:xfrm>
             <a:off x="9006348" y="3599837"/>
-            <a:ext cx="1071716" cy="381000"/>
+            <a:ext cx="1209368" cy="369332"/>
           </a:xfrm>
           <a:prstGeom prst="rect">
             <a:avLst/>
@@ -12705,7 +12705,7 @@
                 <a:effectLst/>
                 <a:latin typeface="+mn-lt"/>
               </a:rPr>
-              <a:t>B &lt;&lt;&lt; 2</a:t>
+              <a:t>B &lt;&lt;&lt; 24</a:t>
             </a:r>
             <a:endParaRPr lang="pt-BR" sz="1050" b="0" i="0" dirty="0">
               <a:solidFill>
@@ -12732,7 +12732,7 @@
         <p:spPr>
           <a:xfrm>
             <a:off x="9006348" y="3062749"/>
-            <a:ext cx="1071716" cy="381000"/>
+            <a:ext cx="1209368" cy="369332"/>
           </a:xfrm>
           <a:prstGeom prst="rect">
             <a:avLst/>
@@ -12756,7 +12756,7 @@
                 <a:effectLst/>
                 <a:latin typeface="+mn-lt"/>
               </a:rPr>
-              <a:t>B &lt;&lt;&lt; 2</a:t>
+              <a:t>B &lt;&lt;&lt; 18</a:t>
             </a:r>
             <a:endParaRPr lang="pt-BR" sz="1050" b="0" i="0" dirty="0">
               <a:solidFill>

</xml_diff>